<commit_message>
Add initial HTML and JavaScript files for interactive DOM manipulation
</commit_message>
<xml_diff>
--- a/Files/JavaScript/6thslidejavascript.pptx
+++ b/Files/JavaScript/6thslidejavascript.pptx
@@ -253,7 +253,7 @@
   </p:defaultTextStyle>
   <p:extLst>
     <p:ext uri="{EFAFB233-063F-42B5-8137-9DF3F51BA10A}">
-      <p15:sldGuideLst xmlns:p15="http://schemas.microsoft.com/office/powerpoint/2012/main" xmlns="">
+      <p15:sldGuideLst xmlns:p15="http://schemas.microsoft.com/office/powerpoint/2012/main">
         <p15:guide id="1" orient="horz" pos="1620">
           <p15:clr>
             <a:srgbClr val="747775"/>
@@ -2531,7 +2531,7 @@
             <a:fld id="{04AF466F-BDA4-4F18-9C7B-FF0A9A1B0E80}" type="datetime1">
               <a:rPr lang="en-US" smtClean="0"/>
               <a:pPr/>
-              <a:t>3/13/2026</a:t>
+              <a:t>3/31/2026</a:t>
             </a:fld>
             <a:endParaRPr lang="en-US"/>
           </a:p>
@@ -2731,7 +2731,7 @@
             <a:fld id="{58FB4290-6522-4139-852E-05BD9E7F0D2E}" type="datetime1">
               <a:rPr lang="en-US" smtClean="0"/>
               <a:pPr/>
-              <a:t>3/13/2026</a:t>
+              <a:t>3/31/2026</a:t>
             </a:fld>
             <a:endParaRPr lang="en-US"/>
           </a:p>
@@ -2916,7 +2916,7 @@
             <a:fld id="{AAB955F9-81EA-47C5-8059-9E5C2B437C70}" type="datetime1">
               <a:rPr lang="en-US" smtClean="0"/>
               <a:pPr/>
-              <a:t>3/13/2026</a:t>
+              <a:t>3/31/2026</a:t>
             </a:fld>
             <a:endParaRPr lang="en-US"/>
           </a:p>
@@ -3431,7 +3431,7 @@
             <a:fld id="{1CEF607B-A47E-422C-9BEF-122CCDB7C526}" type="datetime1">
               <a:rPr lang="en-US" smtClean="0"/>
               <a:pPr/>
-              <a:t>3/13/2026</a:t>
+              <a:t>3/31/2026</a:t>
             </a:fld>
             <a:endParaRPr lang="en-US"/>
           </a:p>
@@ -3687,7 +3687,7 @@
             <a:fld id="{63A9A7CB-BEE6-4F99-898E-913F06E8E125}" type="datetime1">
               <a:rPr lang="en-US" smtClean="0"/>
               <a:pPr/>
-              <a:t>3/13/2026</a:t>
+              <a:t>3/31/2026</a:t>
             </a:fld>
             <a:endParaRPr lang="en-US"/>
           </a:p>
@@ -4097,7 +4097,7 @@
             <a:fld id="{B6EE300C-6FC5-4FC3-AF1A-075E4F50620D}" type="datetime1">
               <a:rPr lang="en-US" smtClean="0"/>
               <a:pPr/>
-              <a:t>3/13/2026</a:t>
+              <a:t>3/31/2026</a:t>
             </a:fld>
             <a:endParaRPr lang="en-US"/>
           </a:p>
@@ -4544,7 +4544,7 @@
             <a:fld id="{F50D295D-4A77-4DEB-B04C-9F4282A8BC04}" type="datetime1">
               <a:rPr lang="en-US" smtClean="0"/>
               <a:pPr/>
-              <a:t>3/13/2026</a:t>
+              <a:t>3/31/2026</a:t>
             </a:fld>
             <a:endParaRPr lang="en-US"/>
           </a:p>
@@ -4650,7 +4650,7 @@
             <a:fld id="{02B28685-4D0C-42D5-8013-B5904CD1FCBC}" type="datetime1">
               <a:rPr lang="en-US" smtClean="0"/>
               <a:pPr/>
-              <a:t>3/13/2026</a:t>
+              <a:t>3/31/2026</a:t>
             </a:fld>
             <a:endParaRPr lang="en-US"/>
           </a:p>
@@ -4773,7 +4773,7 @@
             <a:fld id="{FDF226C0-9885-4BA9-BBFA-A52CBFEBB775}" type="datetime1">
               <a:rPr lang="en-US" smtClean="0"/>
               <a:pPr/>
-              <a:t>3/13/2026</a:t>
+              <a:t>3/31/2026</a:t>
             </a:fld>
             <a:endParaRPr lang="en-US"/>
           </a:p>
@@ -5050,7 +5050,7 @@
             <a:fld id="{EBEE1B38-C5EB-4D66-9137-0AFE9CDEDE8F}" type="datetime1">
               <a:rPr lang="en-US" smtClean="0"/>
               <a:pPr/>
-              <a:t>3/13/2026</a:t>
+              <a:t>3/31/2026</a:t>
             </a:fld>
             <a:endParaRPr lang="en-US"/>
           </a:p>
@@ -5262,7 +5262,7 @@
             <a:fld id="{327B613C-1AD7-49D3-885D-F654C5CDBAA6}" type="datetime1">
               <a:rPr lang="en-US" smtClean="0"/>
               <a:pPr/>
-              <a:t>3/13/2026</a:t>
+              <a:t>3/31/2026</a:t>
             </a:fld>
             <a:endParaRPr lang="en-US" dirty="0"/>
           </a:p>
@@ -6359,7 +6359,7 @@
             <a:fld id="{327B613C-1AD7-49D3-885D-F654C5CDBAA6}" type="datetime1">
               <a:rPr lang="en-US" smtClean="0"/>
               <a:pPr/>
-              <a:t>3/13/2026</a:t>
+              <a:t>3/31/2026</a:t>
             </a:fld>
             <a:endParaRPr lang="en-US" dirty="0"/>
           </a:p>
@@ -6782,7 +6782,7 @@
           <p:cNvPr id="3" name="Rectangle 2">
             <a:extLst>
               <a:ext uri="{FF2B5EF4-FFF2-40B4-BE49-F238E27FC236}">
-                <a16:creationId xmlns:a16="http://schemas.microsoft.com/office/drawing/2014/main" xmlns="" id="{0B71B1BC-C243-4C7F-82D7-6A63E7EFE092}"/>
+                <a16:creationId xmlns:a16="http://schemas.microsoft.com/office/drawing/2014/main" id="{0B71B1BC-C243-4C7F-82D7-6A63E7EFE092}"/>
               </a:ext>
             </a:extLst>
           </p:cNvPr>
@@ -6850,7 +6850,7 @@
           <p:cNvPr id="2" name="Rectangle 1">
             <a:extLst>
               <a:ext uri="{FF2B5EF4-FFF2-40B4-BE49-F238E27FC236}">
-                <a16:creationId xmlns:a16="http://schemas.microsoft.com/office/drawing/2014/main" xmlns="" id="{228FC96F-AA2D-4150-A5A4-F5095D48CF0C}"/>
+                <a16:creationId xmlns:a16="http://schemas.microsoft.com/office/drawing/2014/main" id="{228FC96F-AA2D-4150-A5A4-F5095D48CF0C}"/>
               </a:ext>
             </a:extLst>
           </p:cNvPr>
@@ -7011,7 +7011,7 @@
           <p:cNvPr id="6" name="Rectangle 5">
             <a:extLst>
               <a:ext uri="{FF2B5EF4-FFF2-40B4-BE49-F238E27FC236}">
-                <a16:creationId xmlns:a16="http://schemas.microsoft.com/office/drawing/2014/main" xmlns="" id="{52EC73A5-44C7-46E8-AB3B-57119B14DE17}"/>
+                <a16:creationId xmlns:a16="http://schemas.microsoft.com/office/drawing/2014/main" id="{52EC73A5-44C7-46E8-AB3B-57119B14DE17}"/>
               </a:ext>
             </a:extLst>
           </p:cNvPr>
@@ -7079,7 +7079,7 @@
           <p:cNvPr id="3" name="Rectangle 2">
             <a:extLst>
               <a:ext uri="{FF2B5EF4-FFF2-40B4-BE49-F238E27FC236}">
-                <a16:creationId xmlns:a16="http://schemas.microsoft.com/office/drawing/2014/main" xmlns="" id="{15B7843F-985D-478A-B14C-18CAC4EF64B1}"/>
+                <a16:creationId xmlns:a16="http://schemas.microsoft.com/office/drawing/2014/main" id="{15B7843F-985D-478A-B14C-18CAC4EF64B1}"/>
               </a:ext>
             </a:extLst>
           </p:cNvPr>
@@ -7175,7 +7175,7 @@
           <p:cNvPr id="4" name="Rectangle 3">
             <a:extLst>
               <a:ext uri="{FF2B5EF4-FFF2-40B4-BE49-F238E27FC236}">
-                <a16:creationId xmlns:a16="http://schemas.microsoft.com/office/drawing/2014/main" xmlns="" id="{2C56E732-0195-479B-A4FA-6E787551C953}"/>
+                <a16:creationId xmlns:a16="http://schemas.microsoft.com/office/drawing/2014/main" id="{2C56E732-0195-479B-A4FA-6E787551C953}"/>
               </a:ext>
             </a:extLst>
           </p:cNvPr>
@@ -7396,7 +7396,7 @@
           <p:cNvPr id="2" name="Rectangle 1">
             <a:extLst>
               <a:ext uri="{FF2B5EF4-FFF2-40B4-BE49-F238E27FC236}">
-                <a16:creationId xmlns:a16="http://schemas.microsoft.com/office/drawing/2014/main" xmlns="" id="{25E2E674-828D-43BD-8D6F-63715D24E6DB}"/>
+                <a16:creationId xmlns:a16="http://schemas.microsoft.com/office/drawing/2014/main" id="{25E2E674-828D-43BD-8D6F-63715D24E6DB}"/>
               </a:ext>
             </a:extLst>
           </p:cNvPr>
@@ -7434,7 +7434,7 @@
           <p:cNvPr id="3" name="Rectangle 2">
             <a:extLst>
               <a:ext uri="{FF2B5EF4-FFF2-40B4-BE49-F238E27FC236}">
-                <a16:creationId xmlns:a16="http://schemas.microsoft.com/office/drawing/2014/main" xmlns="" id="{CB9CD371-3DBE-42EE-BA7A-6BB1FFAA0FD9}"/>
+                <a16:creationId xmlns:a16="http://schemas.microsoft.com/office/drawing/2014/main" id="{CB9CD371-3DBE-42EE-BA7A-6BB1FFAA0FD9}"/>
               </a:ext>
             </a:extLst>
           </p:cNvPr>
@@ -7744,7 +7744,7 @@
           <p:cNvPr id="2" name="Rectangle 1">
             <a:extLst>
               <a:ext uri="{FF2B5EF4-FFF2-40B4-BE49-F238E27FC236}">
-                <a16:creationId xmlns:a16="http://schemas.microsoft.com/office/drawing/2014/main" xmlns="" id="{46AA36EE-5190-41B9-974E-5CBA695B726E}"/>
+                <a16:creationId xmlns:a16="http://schemas.microsoft.com/office/drawing/2014/main" id="{46AA36EE-5190-41B9-974E-5CBA695B726E}"/>
               </a:ext>
             </a:extLst>
           </p:cNvPr>
@@ -7833,7 +7833,7 @@
           <p:cNvPr id="3" name="Rectangle 2">
             <a:extLst>
               <a:ext uri="{FF2B5EF4-FFF2-40B4-BE49-F238E27FC236}">
-                <a16:creationId xmlns:a16="http://schemas.microsoft.com/office/drawing/2014/main" xmlns="" id="{1023970D-3E26-43D2-97D2-2FE75610755D}"/>
+                <a16:creationId xmlns:a16="http://schemas.microsoft.com/office/drawing/2014/main" id="{1023970D-3E26-43D2-97D2-2FE75610755D}"/>
               </a:ext>
             </a:extLst>
           </p:cNvPr>
@@ -7995,7 +7995,7 @@
           <p:cNvPr id="3" name="Rectangle 2">
             <a:extLst>
               <a:ext uri="{FF2B5EF4-FFF2-40B4-BE49-F238E27FC236}">
-                <a16:creationId xmlns:a16="http://schemas.microsoft.com/office/drawing/2014/main" xmlns="" id="{6BB24B8A-0761-4E7F-BB22-0E89A870E6C0}"/>
+                <a16:creationId xmlns:a16="http://schemas.microsoft.com/office/drawing/2014/main" id="{6BB24B8A-0761-4E7F-BB22-0E89A870E6C0}"/>
               </a:ext>
             </a:extLst>
           </p:cNvPr>
@@ -8467,7 +8467,7 @@
           <p:cNvPr id="2" name="Rectangle 1">
             <a:extLst>
               <a:ext uri="{FF2B5EF4-FFF2-40B4-BE49-F238E27FC236}">
-                <a16:creationId xmlns:a16="http://schemas.microsoft.com/office/drawing/2014/main" xmlns="" id="{767A955E-2F34-4D87-83B8-F3829A9AF244}"/>
+                <a16:creationId xmlns:a16="http://schemas.microsoft.com/office/drawing/2014/main" id="{767A955E-2F34-4D87-83B8-F3829A9AF244}"/>
               </a:ext>
             </a:extLst>
           </p:cNvPr>
@@ -8515,7 +8515,7 @@
           <p:cNvPr id="4" name="Rectangle 3">
             <a:extLst>
               <a:ext uri="{FF2B5EF4-FFF2-40B4-BE49-F238E27FC236}">
-                <a16:creationId xmlns:a16="http://schemas.microsoft.com/office/drawing/2014/main" xmlns="" id="{D987B300-7EE6-4468-B3D4-2F85121A6D13}"/>
+                <a16:creationId xmlns:a16="http://schemas.microsoft.com/office/drawing/2014/main" id="{D987B300-7EE6-4468-B3D4-2F85121A6D13}"/>
               </a:ext>
             </a:extLst>
           </p:cNvPr>
@@ -8752,7 +8752,7 @@
           <p:cNvPr id="2" name="Rectangle 1">
             <a:extLst>
               <a:ext uri="{FF2B5EF4-FFF2-40B4-BE49-F238E27FC236}">
-                <a16:creationId xmlns:a16="http://schemas.microsoft.com/office/drawing/2014/main" xmlns="" id="{3C8F2440-FA31-4DEA-9D93-CE879E3F51E2}"/>
+                <a16:creationId xmlns:a16="http://schemas.microsoft.com/office/drawing/2014/main" id="{3C8F2440-FA31-4DEA-9D93-CE879E3F51E2}"/>
               </a:ext>
             </a:extLst>
           </p:cNvPr>
@@ -9080,7 +9080,7 @@
           <p:cNvPr id="3" name="Rectangle 2">
             <a:extLst>
               <a:ext uri="{FF2B5EF4-FFF2-40B4-BE49-F238E27FC236}">
-                <a16:creationId xmlns:a16="http://schemas.microsoft.com/office/drawing/2014/main" xmlns="" id="{B5C99F7C-B952-4AB4-AF2C-6F1B55A84E93}"/>
+                <a16:creationId xmlns:a16="http://schemas.microsoft.com/office/drawing/2014/main" id="{B5C99F7C-B952-4AB4-AF2C-6F1B55A84E93}"/>
               </a:ext>
             </a:extLst>
           </p:cNvPr>
@@ -9244,7 +9244,7 @@
           <p:cNvPr id="2" name="Rectangle 1">
             <a:extLst>
               <a:ext uri="{FF2B5EF4-FFF2-40B4-BE49-F238E27FC236}">
-                <a16:creationId xmlns:a16="http://schemas.microsoft.com/office/drawing/2014/main" xmlns="" id="{2674AA80-C45D-4A72-8763-7CD9C59BEC16}"/>
+                <a16:creationId xmlns:a16="http://schemas.microsoft.com/office/drawing/2014/main" id="{2674AA80-C45D-4A72-8763-7CD9C59BEC16}"/>
               </a:ext>
             </a:extLst>
           </p:cNvPr>
@@ -9817,7 +9817,7 @@
           <p:cNvPr id="4" name="Rectangle 3">
             <a:extLst>
               <a:ext uri="{FF2B5EF4-FFF2-40B4-BE49-F238E27FC236}">
-                <a16:creationId xmlns:a16="http://schemas.microsoft.com/office/drawing/2014/main" xmlns="" id="{45957344-A9E2-479F-B646-45EDC7196527}"/>
+                <a16:creationId xmlns:a16="http://schemas.microsoft.com/office/drawing/2014/main" id="{45957344-A9E2-479F-B646-45EDC7196527}"/>
               </a:ext>
             </a:extLst>
           </p:cNvPr>

</xml_diff>